<commit_message>
:wqmade improvements in the ppt style also added convo follow up feature
</commit_message>
<xml_diff>
--- a/reports/eda_presentation_report.pptx
+++ b/reports/eda_presentation_report.pptx
@@ -9,9 +9,8 @@
     <p:sldId id="257" r:id="rId8"/>
     <p:sldId id="258" r:id="rId9"/>
     <p:sldId id="259" r:id="rId10"/>
-    <p:sldId id="260" r:id="rId11"/>
   </p:sldIdLst>
-  <p:sldSz cx="9144000" cy="6858000" type="screen4x3"/>
+  <p:sldSz cx="12188952" cy="6858000" type="screen4x3"/>
   <p:notesSz cx="6858000" cy="9144000"/>
   <p:defaultTextStyle>
     <a:defPPr>
@@ -3094,42 +3093,50 @@
       <p:grpSpPr/>
       <p:sp>
         <p:nvSpPr>
-          <p:cNvPr id="2" name="Title 1"/>
-          <p:cNvSpPr>
-            <a:spLocks noGrp="1"/>
-          </p:cNvSpPr>
-          <p:nvPr>
-            <p:ph type="ctrTitle"/>
-          </p:nvPr>
-        </p:nvSpPr>
-        <p:spPr/>
-        <p:txBody>
-          <a:bodyPr/>
-          <a:lstStyle/>
-          <a:p>
+          <p:cNvPr id="2" name="TextBox 1"/>
+          <p:cNvSpPr txBox="1"/>
+          <p:nvPr/>
+        </p:nvSpPr>
+        <p:spPr>
+          <a:xfrm>
+            <a:off x="1097280" y="2011680"/>
+            <a:ext cx="10058400" cy="2286000"/>
+          </a:xfrm>
+          <a:prstGeom prst="rect">
+            <a:avLst/>
+          </a:prstGeom>
+          <a:noFill/>
+        </p:spPr>
+        <p:txBody>
+          <a:bodyPr wrap="square">
+            <a:spAutoFit/>
+          </a:bodyPr>
+          <a:lstStyle/>
+          <a:p>
+            <a:pPr>
+              <a:defRPr sz="4000" b="1">
+                <a:solidFill>
+                  <a:srgbClr val="16213E"/>
+                </a:solidFill>
+              </a:defRPr>
+            </a:pPr>
             <a:r>
               <a:t>DataNova: Automated EDA Report</a:t>
             </a:r>
           </a:p>
-        </p:txBody>
-      </p:sp>
-      <p:sp>
-        <p:nvSpPr>
-          <p:cNvPr id="3" name="Subtitle 2"/>
-          <p:cNvSpPr>
-            <a:spLocks noGrp="1"/>
-          </p:cNvSpPr>
-          <p:nvPr>
-            <p:ph type="subTitle" idx="1"/>
-          </p:nvPr>
-        </p:nvSpPr>
-        <p:spPr/>
-        <p:txBody>
-          <a:bodyPr/>
-          <a:lstStyle/>
-          <a:p>
-            <a:r>
-              <a:t>Domain Detected: Healthcare</a:t>
+          <a:p>
+            <a:pPr>
+              <a:spcBef>
+                <a:spcPts val="1600"/>
+              </a:spcBef>
+              <a:defRPr sz="2000">
+                <a:solidFill>
+                  <a:srgbClr val="0066CC"/>
+                </a:solidFill>
+              </a:defRPr>
+            </a:pPr>
+            <a:r>
+              <a:t>Detected Domain: Generic | Automated Intelligence Engine</a:t>
             </a:r>
           </a:p>
         </p:txBody>
@@ -3154,45 +3161,105 @@
       <p:grpSpPr/>
       <p:sp>
         <p:nvSpPr>
-          <p:cNvPr id="2" name="Title 1"/>
-          <p:cNvSpPr>
-            <a:spLocks noGrp="1"/>
-          </p:cNvSpPr>
-          <p:nvPr>
-            <p:ph type="title"/>
-          </p:nvPr>
-        </p:nvSpPr>
-        <p:spPr/>
-        <p:txBody>
-          <a:bodyPr/>
-          <a:lstStyle/>
-          <a:p>
-            <a:r>
-              <a:t>Executive / Dataset Overview  </a:t>
-            </a:r>
-          </a:p>
-          <a:p>
-            <a:r>
-              <a:t>- Healthcare-focused patient </a:t>
-            </a:r>
-          </a:p>
-        </p:txBody>
-      </p:sp>
-      <p:sp>
-        <p:nvSpPr>
-          <p:cNvPr id="3" name="Content Placeholder 2"/>
-          <p:cNvSpPr>
-            <a:spLocks noGrp="1"/>
-          </p:cNvSpPr>
-          <p:nvPr>
-            <p:ph idx="1"/>
-          </p:nvPr>
-        </p:nvSpPr>
-        <p:spPr/>
-        <p:txBody>
-          <a:bodyPr/>
-          <a:lstStyle/>
-          <a:p/>
+          <p:cNvPr id="2" name="TextBox 1"/>
+          <p:cNvSpPr txBox="1"/>
+          <p:nvPr/>
+        </p:nvSpPr>
+        <p:spPr>
+          <a:xfrm>
+            <a:off x="914400" y="731520"/>
+            <a:ext cx="10360152" cy="731520"/>
+          </a:xfrm>
+          <a:prstGeom prst="rect">
+            <a:avLst/>
+          </a:prstGeom>
+          <a:noFill/>
+        </p:spPr>
+        <p:txBody>
+          <a:bodyPr wrap="none">
+            <a:spAutoFit/>
+          </a:bodyPr>
+          <a:lstStyle/>
+          <a:p>
+            <a:pPr>
+              <a:defRPr sz="2800" b="1">
+                <a:solidFill>
+                  <a:srgbClr val="16213E"/>
+                </a:solidFill>
+              </a:defRPr>
+            </a:pPr>
+            <a:r>
+              <a:t>Executive / Dataset Overview</a:t>
+            </a:r>
+          </a:p>
+        </p:txBody>
+      </p:sp>
+      <p:sp>
+        <p:nvSpPr>
+          <p:cNvPr id="3" name="TextBox 2"/>
+          <p:cNvSpPr txBox="1"/>
+          <p:nvPr/>
+        </p:nvSpPr>
+        <p:spPr>
+          <a:xfrm>
+            <a:off x="914400" y="1645920"/>
+            <a:ext cx="10360152" cy="4572000"/>
+          </a:xfrm>
+          <a:prstGeom prst="rect">
+            <a:avLst/>
+          </a:prstGeom>
+          <a:noFill/>
+        </p:spPr>
+        <p:txBody>
+          <a:bodyPr wrap="square">
+            <a:spAutoFit/>
+          </a:bodyPr>
+          <a:lstStyle/>
+          <a:p>
+            <a:pPr>
+              <a:spcAft>
+                <a:spcPts val="1400"/>
+              </a:spcAft>
+              <a:defRPr sz="1800">
+                <a:solidFill>
+                  <a:srgbClr val="282828"/>
+                </a:solidFill>
+              </a:defRPr>
+            </a:pPr>
+            <a:r>
+              <a:t>•  1,000,000 observations across 10 agronomic variables capture regional crop performance.</a:t>
+            </a:r>
+          </a:p>
+          <a:p>
+            <a:pPr>
+              <a:spcAft>
+                <a:spcPts val="1400"/>
+              </a:spcAft>
+              <a:defRPr sz="1800">
+                <a:solidFill>
+                  <a:srgbClr val="282828"/>
+                </a:solidFill>
+              </a:defRPr>
+            </a:pPr>
+            <a:r>
+              <a:t>•  Core fields: Region, Soil_Type, Crop, Rainfall_mm, Temperature_Celsius, Fertilizer_Used, Irrigation_Used, Weather_Condition, Days_to_Harvest, Yield_tons_per_hectare.</a:t>
+            </a:r>
+          </a:p>
+          <a:p>
+            <a:pPr>
+              <a:spcAft>
+                <a:spcPts val="1400"/>
+              </a:spcAft>
+              <a:defRPr sz="1800">
+                <a:solidFill>
+                  <a:srgbClr val="282828"/>
+                </a:solidFill>
+              </a:defRPr>
+            </a:pPr>
+            <a:r>
+              <a:t>•  Categorical attributes (Region, Soil_Type, Crop, Weather_Condition) enable segmentation; numeric metrics (Rainfall, Temperature, Days_to_Harvest, Yield) drive yield modeling.</a:t>
+            </a:r>
+          </a:p>
         </p:txBody>
       </p:sp>
     </p:spTree>
@@ -3215,65 +3282,103 @@
       <p:grpSpPr/>
       <p:sp>
         <p:nvSpPr>
-          <p:cNvPr id="2" name="Title 1"/>
-          <p:cNvSpPr>
-            <a:spLocks noGrp="1"/>
-          </p:cNvSpPr>
-          <p:nvPr>
-            <p:ph type="title"/>
-          </p:nvPr>
-        </p:nvSpPr>
-        <p:spPr/>
-        <p:txBody>
-          <a:bodyPr/>
-          <a:lstStyle/>
-          <a:p>
-            <a:r>
-              <a:t>Data Quality &amp; Profiling Insights  </a:t>
-            </a:r>
-          </a:p>
-          <a:p>
-            <a:r>
-              <a:t>- No missing values or d</a:t>
-            </a:r>
-          </a:p>
-        </p:txBody>
-      </p:sp>
-      <p:sp>
-        <p:nvSpPr>
-          <p:cNvPr id="3" name="Content Placeholder 2"/>
-          <p:cNvSpPr>
-            <a:spLocks noGrp="1"/>
-          </p:cNvSpPr>
-          <p:nvPr>
-            <p:ph idx="1"/>
-          </p:nvPr>
-        </p:nvSpPr>
-        <p:spPr/>
-        <p:txBody>
-          <a:bodyPr/>
-          <a:lstStyle/>
-          <a:p/>
-          <a:p>
-            <a:pPr/>
-            <a:r>
-              <a:t>the table is clean from a completeness standpoint.  </a:t>
-            </a:r>
-            <a:br/>
-            <a:r>
-              <a:t>- Two age outliers (21 y, 38 y) fall below the calculated lower bound (39 y); they represent &lt; 1 % of the sample and may be genuine younger patients or data entry errors.  </a:t>
-            </a:r>
-            <a:br/>
-            <a:r>
-              <a:t>- Column names contain trailing spaces ("FATIGUE ", "ALLERGY ") and inconsistent spacing ("CHRONIC DISEASE" vs "CHRONIC_DISEASE"). These will need standardisation before modeling.  </a:t>
-            </a:r>
-            <a:br/>
-            <a:r>
-              <a:t>- All symptom and exposure fields are encoded as integers, likely 0/1; verify that no values exceed this range.  </a:t>
-            </a:r>
-            <a:br/>
-            <a:r>
-              <a:t>- Gender is the only non-numeric field; ensure consistent labeling (e.g., "Male", "Female", "M", "F").</a:t>
+          <p:cNvPr id="2" name="TextBox 1"/>
+          <p:cNvSpPr txBox="1"/>
+          <p:nvPr/>
+        </p:nvSpPr>
+        <p:spPr>
+          <a:xfrm>
+            <a:off x="914400" y="731520"/>
+            <a:ext cx="10360152" cy="731520"/>
+          </a:xfrm>
+          <a:prstGeom prst="rect">
+            <a:avLst/>
+          </a:prstGeom>
+          <a:noFill/>
+        </p:spPr>
+        <p:txBody>
+          <a:bodyPr wrap="none">
+            <a:spAutoFit/>
+          </a:bodyPr>
+          <a:lstStyle/>
+          <a:p>
+            <a:pPr>
+              <a:defRPr sz="2800" b="1">
+                <a:solidFill>
+                  <a:srgbClr val="16213E"/>
+                </a:solidFill>
+              </a:defRPr>
+            </a:pPr>
+            <a:r>
+              <a:t>Data Quality &amp; Profiling Insights</a:t>
+            </a:r>
+          </a:p>
+        </p:txBody>
+      </p:sp>
+      <p:sp>
+        <p:nvSpPr>
+          <p:cNvPr id="3" name="TextBox 2"/>
+          <p:cNvSpPr txBox="1"/>
+          <p:nvPr/>
+        </p:nvSpPr>
+        <p:spPr>
+          <a:xfrm>
+            <a:off x="914400" y="1645920"/>
+            <a:ext cx="10360152" cy="4572000"/>
+          </a:xfrm>
+          <a:prstGeom prst="rect">
+            <a:avLst/>
+          </a:prstGeom>
+          <a:noFill/>
+        </p:spPr>
+        <p:txBody>
+          <a:bodyPr wrap="square">
+            <a:spAutoFit/>
+          </a:bodyPr>
+          <a:lstStyle/>
+          <a:p>
+            <a:pPr>
+              <a:spcAft>
+                <a:spcPts val="1400"/>
+              </a:spcAft>
+              <a:defRPr sz="1800">
+                <a:solidFill>
+                  <a:srgbClr val="282828"/>
+                </a:solidFill>
+              </a:defRPr>
+            </a:pPr>
+            <a:r>
+              <a:t>•  Zero missing values and consistent dtypes indicate a clean, ready-to-model dataset.</a:t>
+            </a:r>
+          </a:p>
+          <a:p>
+            <a:pPr>
+              <a:spcAft>
+                <a:spcPts val="1400"/>
+              </a:spcAft>
+              <a:defRPr sz="1800">
+                <a:solidFill>
+                  <a:srgbClr val="282828"/>
+                </a:solidFill>
+              </a:defRPr>
+            </a:pPr>
+            <a:r>
+              <a:t>•  Yield outliers: 84 records exceed plausible bounds (-0.27 - 9.57 t/ha), with extreme values up to 9.73 t/ha and negatives down to -0.84 t/ha.</a:t>
+            </a:r>
+          </a:p>
+          <a:p>
+            <a:pPr>
+              <a:spcAft>
+                <a:spcPts val="1400"/>
+              </a:spcAft>
+              <a:defRPr sz="1800">
+                <a:solidFill>
+                  <a:srgbClr val="282828"/>
+                </a:solidFill>
+              </a:defRPr>
+            </a:pPr>
+            <a:r>
+              <a:t>•  Outlier rows are sparsely distributed (sample indices: 11 596, 39 669, 54 745, 77 504, 93 760), suggesting isolated data-entry errors rather than systemic bias.</a:t>
             </a:r>
           </a:p>
         </p:txBody>
@@ -3298,101 +3403,135 @@
       <p:grpSpPr/>
       <p:sp>
         <p:nvSpPr>
-          <p:cNvPr id="2" name="Title 1"/>
-          <p:cNvSpPr>
-            <a:spLocks noGrp="1"/>
-          </p:cNvSpPr>
-          <p:nvPr>
-            <p:ph type="title"/>
-          </p:nvPr>
-        </p:nvSpPr>
-        <p:spPr/>
-        <p:txBody>
-          <a:bodyPr/>
-          <a:lstStyle/>
-          <a:p>
-            <a:r>
-              <a:t>Strategic / Operational Takeaways  </a:t>
-            </a:r>
-          </a:p>
-          <a:p>
-            <a:r>
-              <a:t>- Immediate data-cleanin</a:t>
-            </a:r>
-          </a:p>
-        </p:txBody>
-      </p:sp>
-      <p:sp>
-        <p:nvSpPr>
-          <p:cNvPr id="3" name="Content Placeholder 2"/>
-          <p:cNvSpPr>
-            <a:spLocks noGrp="1"/>
-          </p:cNvSpPr>
-          <p:nvPr>
-            <p:ph idx="1"/>
-          </p:nvPr>
-        </p:nvSpPr>
-        <p:spPr/>
-        <p:txBody>
-          <a:bodyPr/>
-          <a:lstStyle/>
-          <a:p/>
-        </p:txBody>
-      </p:sp>
-    </p:spTree>
-  </p:cSld>
-  <p:clrMapOvr>
-    <a:masterClrMapping/>
-  </p:clrMapOvr>
-</p:sld>
-</file>
-
-<file path=ppt/slides/slide5.xml><?xml version="1.0" encoding="utf-8"?>
-<p:sld xmlns:a="http://schemas.openxmlformats.org/drawingml/2006/main" xmlns:p="http://schemas.openxmlformats.org/presentationml/2006/main" xmlns:r="http://schemas.openxmlformats.org/officeDocument/2006/relationships">
-  <p:cSld>
-    <p:spTree>
-      <p:nvGrpSpPr>
-        <p:cNvPr id="1" name=""/>
-        <p:cNvGrpSpPr/>
-        <p:nvPr/>
-      </p:nvGrpSpPr>
-      <p:grpSpPr/>
-      <p:sp>
-        <p:nvSpPr>
-          <p:cNvPr id="2" name="Title 1"/>
-          <p:cNvSpPr>
-            <a:spLocks noGrp="1"/>
-          </p:cNvSpPr>
-          <p:nvPr>
-            <p:ph type="title"/>
-          </p:nvPr>
-        </p:nvSpPr>
-        <p:spPr/>
-        <p:txBody>
-          <a:bodyPr/>
-          <a:lstStyle/>
-          <a:p>
-            <a:r>
-              <a:t>End of Report.</a:t>
-            </a:r>
-          </a:p>
-        </p:txBody>
-      </p:sp>
-      <p:sp>
-        <p:nvSpPr>
-          <p:cNvPr id="3" name="Content Placeholder 2"/>
-          <p:cNvSpPr>
-            <a:spLocks noGrp="1"/>
-          </p:cNvSpPr>
-          <p:nvPr>
-            <p:ph idx="1"/>
-          </p:nvPr>
-        </p:nvSpPr>
-        <p:spPr/>
-        <p:txBody>
-          <a:bodyPr/>
-          <a:lstStyle/>
-          <a:p/>
+          <p:cNvPr id="2" name="TextBox 1"/>
+          <p:cNvSpPr txBox="1"/>
+          <p:nvPr/>
+        </p:nvSpPr>
+        <p:spPr>
+          <a:xfrm>
+            <a:off x="914400" y="731520"/>
+            <a:ext cx="10360152" cy="731520"/>
+          </a:xfrm>
+          <a:prstGeom prst="rect">
+            <a:avLst/>
+          </a:prstGeom>
+          <a:noFill/>
+        </p:spPr>
+        <p:txBody>
+          <a:bodyPr wrap="none">
+            <a:spAutoFit/>
+          </a:bodyPr>
+          <a:lstStyle/>
+          <a:p>
+            <a:pPr>
+              <a:defRPr sz="2800" b="1">
+                <a:solidFill>
+                  <a:srgbClr val="16213E"/>
+                </a:solidFill>
+              </a:defRPr>
+            </a:pPr>
+            <a:r>
+              <a:t>Strategic / Operational Takeaways</a:t>
+            </a:r>
+          </a:p>
+        </p:txBody>
+      </p:sp>
+      <p:sp>
+        <p:nvSpPr>
+          <p:cNvPr id="3" name="TextBox 2"/>
+          <p:cNvSpPr txBox="1"/>
+          <p:nvPr/>
+        </p:nvSpPr>
+        <p:spPr>
+          <a:xfrm>
+            <a:off x="914400" y="1645920"/>
+            <a:ext cx="10360152" cy="4572000"/>
+          </a:xfrm>
+          <a:prstGeom prst="rect">
+            <a:avLst/>
+          </a:prstGeom>
+          <a:noFill/>
+        </p:spPr>
+        <p:txBody>
+          <a:bodyPr wrap="square">
+            <a:spAutoFit/>
+          </a:bodyPr>
+          <a:lstStyle/>
+          <a:p>
+            <a:pPr>
+              <a:spcAft>
+                <a:spcPts val="1400"/>
+              </a:spcAft>
+              <a:defRPr sz="1800">
+                <a:solidFill>
+                  <a:srgbClr val="282828"/>
+                </a:solidFill>
+              </a:defRPr>
+            </a:pPr>
+            <a:r>
+              <a:t>•  Flag and review the 84 yield outliers; consider capping or imputing to prevent distortion of predictive models.</a:t>
+            </a:r>
+          </a:p>
+          <a:p>
+            <a:pPr>
+              <a:spcAft>
+                <a:spcPts val="1400"/>
+              </a:spcAft>
+              <a:defRPr sz="1800">
+                <a:solidFill>
+                  <a:srgbClr val="282828"/>
+                </a:solidFill>
+              </a:defRPr>
+            </a:pPr>
+            <a:r>
+              <a:t>•  Leverage the rich categorical dimensions (Region, Soil_Type, Crop) for targeted agronomic recommendations and region-specific yield forecasts.</a:t>
+            </a:r>
+          </a:p>
+          <a:p>
+            <a:pPr>
+              <a:spcAft>
+                <a:spcPts val="1400"/>
+              </a:spcAft>
+              <a:defRPr sz="1800">
+                <a:solidFill>
+                  <a:srgbClr val="282828"/>
+                </a:solidFill>
+              </a:defRPr>
+            </a:pPr>
+            <a:r>
+              <a:t>•  Integrate rainfall, temperature, and irrigation flags into a multivariate model to quantify climate-driven yield variability.</a:t>
+            </a:r>
+          </a:p>
+          <a:p>
+            <a:pPr>
+              <a:spcAft>
+                <a:spcPts val="1400"/>
+              </a:spcAft>
+              <a:defRPr sz="1800">
+                <a:solidFill>
+                  <a:srgbClr val="282828"/>
+                </a:solidFill>
+              </a:defRPr>
+            </a:pPr>
+            <a:r>
+              <a:t>•  Use Days_to_Harvest as a proxy for crop cycle efficiency; shorter cycles coupled with optimal inputs may boost per-hectare productivity.</a:t>
+            </a:r>
+          </a:p>
+          <a:p>
+            <a:pPr>
+              <a:spcAft>
+                <a:spcPts val="1400"/>
+              </a:spcAft>
+              <a:defRPr sz="1800">
+                <a:solidFill>
+                  <a:srgbClr val="282828"/>
+                </a:solidFill>
+              </a:defRPr>
+            </a:pPr>
+            <a:r>
+              <a:t>•  Deploy the clean dataset in a real-time dashboard for agronomists to monitor input-output relationships and guide precision-farming decisions.</a:t>
+            </a:r>
+          </a:p>
         </p:txBody>
       </p:sp>
     </p:spTree>

</xml_diff>

<commit_message>
changes in reporter.py and then chat_followup
</commit_message>
<xml_diff>
--- a/reports/eda_presentation_report.pptx
+++ b/reports/eda_presentation_report.pptx
@@ -3136,7 +3136,7 @@
               </a:defRPr>
             </a:pPr>
             <a:r>
-              <a:t>Detected Domain: Generic | Automated Intelligence Engine</a:t>
+              <a:t>Detected Domain: Healthcare | Automated Intelligence Engine</a:t>
             </a:r>
           </a:p>
         </p:txBody>
@@ -3227,7 +3227,7 @@
               </a:defRPr>
             </a:pPr>
             <a:r>
-              <a:t>•  1,000,000 observations across 10 agronomic variables capture regional crop performance.</a:t>
+              <a:t>•  309 patient records, 16 variables capture demographics, lifestyle, symptoms, and lung-cancer outcome.</a:t>
             </a:r>
           </a:p>
           <a:p>
@@ -3242,7 +3242,7 @@
               </a:defRPr>
             </a:pPr>
             <a:r>
-              <a:t>•  Core fields: Region, Soil_Type, Crop, Rainfall_mm, Temperature_Celsius, Fertilizer_Used, Irrigation_Used, Weather_Condition, Days_to_Harvest, Yield_tons_per_hectare.</a:t>
+              <a:t>•  Binary/ordinal features (e.g., SMOKING, YELLOW_FINGERS) are encoded as integers, enabling rapid modeling.</a:t>
             </a:r>
           </a:p>
           <a:p>
@@ -3257,7 +3257,22 @@
               </a:defRPr>
             </a:pPr>
             <a:r>
-              <a:t>•  Categorical attributes (Region, Soil_Type, Crop, Weather_Condition) enable segmentation; numeric metrics (Rainfall, Temperature, Days_to_Harvest, Yield) drive yield modeling.</a:t>
+              <a:t>•  Target variable LUNG_CANCER is categorical (likely "YES/NO"), suitable for classification tasks.</a:t>
+            </a:r>
+          </a:p>
+          <a:p>
+            <a:pPr>
+              <a:spcAft>
+                <a:spcPts val="1400"/>
+              </a:spcAft>
+              <a:defRPr sz="1800">
+                <a:solidFill>
+                  <a:srgbClr val="282828"/>
+                </a:solidFill>
+              </a:defRPr>
+            </a:pPr>
+            <a:r>
+              <a:t>•  Age spans 21-87 years, with a median around the mid-50s, reflecting a typical at-risk population.</a:t>
             </a:r>
           </a:p>
         </p:txBody>
@@ -3348,7 +3363,7 @@
               </a:defRPr>
             </a:pPr>
             <a:r>
-              <a:t>•  Zero missing values and consistent dtypes indicate a clean, ready-to-model dataset.</a:t>
+              <a:t>•  No missing values or dtype mismatches; the dataset is clean and ready for analysis.</a:t>
             </a:r>
           </a:p>
           <a:p>
@@ -3363,7 +3378,7 @@
               </a:defRPr>
             </a:pPr>
             <a:r>
-              <a:t>•  Yield outliers: 84 records exceed plausible bounds (-0.27 - 9.57 t/ha), with extreme values up to 9.73 t/ha and negatives down to -0.84 t/ha.</a:t>
+              <a:t>•  Age outliers (21, 38) fall below the statistical lower bound (39) but are clinically plausible; consider capping or flagging.</a:t>
             </a:r>
           </a:p>
           <a:p>
@@ -3378,7 +3393,22 @@
               </a:defRPr>
             </a:pPr>
             <a:r>
-              <a:t>•  Outlier rows are sparsely distributed (sample indices: 11 596, 39 669, 54 745, 77 504, 93 760), suggesting isolated data-entry errors rather than systemic bias.</a:t>
+              <a:t>•  Column names contain trailing spaces (e.g., "FATIGUE ", "ALLERGY "); trim whitespace to avoid downstream bugs.</a:t>
+            </a:r>
+          </a:p>
+          <a:p>
+            <a:pPr>
+              <a:spcAft>
+                <a:spcPts val="1400"/>
+              </a:spcAft>
+              <a:defRPr sz="1800">
+                <a:solidFill>
+                  <a:srgbClr val="282828"/>
+                </a:solidFill>
+              </a:defRPr>
+            </a:pPr>
+            <a:r>
+              <a:t>•  All symptom scores are integer-scaled, likely 0-1 or 0-2; verify the coding scheme before model training.</a:t>
             </a:r>
           </a:p>
         </p:txBody>
@@ -3469,7 +3499,7 @@
               </a:defRPr>
             </a:pPr>
             <a:r>
-              <a:t>•  Flag and review the 84 yield outliers; consider capping or imputing to prevent distortion of predictive models.</a:t>
+              <a:t>•  Immediate next step: encode categorical gender and target, and standardize feature names for reproducibility.</a:t>
             </a:r>
           </a:p>
           <a:p>
@@ -3484,7 +3514,7 @@
               </a:defRPr>
             </a:pPr>
             <a:r>
-              <a:t>•  Leverage the rich categorical dimensions (Region, Soil_Type, Crop) for targeted agronomic recommendations and region-specific yield forecasts.</a:t>
+              <a:t>•  Explore age-stratified risk; the two younger outliers may reveal early-onset patterns worth investigating.</a:t>
             </a:r>
           </a:p>
           <a:p>
@@ -3499,7 +3529,7 @@
               </a:defRPr>
             </a:pPr>
             <a:r>
-              <a:t>•  Integrate rainfall, temperature, and irrigation flags into a multivariate model to quantify climate-driven yield variability.</a:t>
+              <a:t>•  Leverage the fully observed dataset to prototype rapid lung-cancer risk models (logistic regression, tree-based) for clinical decision support.</a:t>
             </a:r>
           </a:p>
           <a:p>
@@ -3514,22 +3544,7 @@
               </a:defRPr>
             </a:pPr>
             <a:r>
-              <a:t>•  Use Days_to_Harvest as a proxy for crop cycle efficiency; shorter cycles coupled with optimal inputs may boost per-hectare productivity.</a:t>
-            </a:r>
-          </a:p>
-          <a:p>
-            <a:pPr>
-              <a:spcAft>
-                <a:spcPts val="1400"/>
-              </a:spcAft>
-              <a:defRPr sz="1800">
-                <a:solidFill>
-                  <a:srgbClr val="282828"/>
-                </a:solidFill>
-              </a:defRPr>
-            </a:pPr>
-            <a:r>
-              <a:t>•  Deploy the clean dataset in a real-time dashboard for agronomists to monitor input-output relationships and guide precision-farming decisions.</a:t>
+              <a:t>•  Prioritize feature importance analysis to identify high-impact symptoms (e.g., YELLOW_FINGERS, WHEEZING) for targeted screening programs.</a:t>
             </a:r>
           </a:p>
         </p:txBody>

</xml_diff>

<commit_message>
minor updates, modified requirements.txt
</commit_message>
<xml_diff>
--- a/reports/eda_presentation_report.pptx
+++ b/reports/eda_presentation_report.pptx
@@ -9,6 +9,8 @@
     <p:sldId id="257" r:id="rId8"/>
     <p:sldId id="258" r:id="rId9"/>
     <p:sldId id="259" r:id="rId10"/>
+    <p:sldId id="260" r:id="rId11"/>
+    <p:sldId id="261" r:id="rId12"/>
   </p:sldIdLst>
   <p:sldSz cx="12188952" cy="6858000" type="screen4x3"/>
   <p:notesSz cx="6858000" cy="9144000"/>
@@ -3227,7 +3229,7 @@
               </a:defRPr>
             </a:pPr>
             <a:r>
-              <a:t>•  309 patient records, 16 variables capture demographics, lifestyle, symptoms, and lung-cancer outcome.</a:t>
+              <a:t>•  309 patient records covering 16 health-related variables, including demographics, lifestyle factors, and symptom scores.</a:t>
             </a:r>
           </a:p>
           <a:p>
@@ -3242,7 +3244,7 @@
               </a:defRPr>
             </a:pPr>
             <a:r>
-              <a:t>•  Binary/ordinal features (e.g., SMOKING, YELLOW_FINGERS) are encoded as integers, enabling rapid modeling.</a:t>
+              <a:t>•  Target variable LUNG_CANCER is categorical, enabling binary classification of disease presence.</a:t>
             </a:r>
           </a:p>
           <a:p>
@@ -3257,7 +3259,7 @@
               </a:defRPr>
             </a:pPr>
             <a:r>
-              <a:t>•  Target variable LUNG_CANCER is categorical (likely "YES/NO"), suitable for classification tasks.</a:t>
+              <a:t>•  Age spans 21-87 years, with a median around mid-50s, reflecting a typical adult patient cohort.</a:t>
             </a:r>
           </a:p>
           <a:p>
@@ -3272,7 +3274,7 @@
               </a:defRPr>
             </a:pPr>
             <a:r>
-              <a:t>•  Age spans 21-87 years, with a median around the mid-50s, reflecting a typical at-risk population.</a:t>
+              <a:t>•  Gender is the sole non-numeric feature; all other predictors are integer-encoded symptom/behavior scores.</a:t>
             </a:r>
           </a:p>
         </p:txBody>
@@ -3363,7 +3365,7 @@
               </a:defRPr>
             </a:pPr>
             <a:r>
-              <a:t>•  No missing values or dtype mismatches; the dataset is clean and ready for analysis.</a:t>
+              <a:t>•  No missing values or dtype mismatches - the dataset is clean and ready for modeling.</a:t>
             </a:r>
           </a:p>
           <a:p>
@@ -3378,7 +3380,7 @@
               </a:defRPr>
             </a:pPr>
             <a:r>
-              <a:t>•  Age outliers (21, 38) fall below the statistical lower bound (39) but are clinically plausible; consider capping or flagging.</a:t>
+              <a:t>•  Age outliers (21 y, 38 y) fall below the calculated lower bound (39 y) but are clinically plausible; consider capping or flagging.</a:t>
             </a:r>
           </a:p>
           <a:p>
@@ -3393,7 +3395,7 @@
               </a:defRPr>
             </a:pPr>
             <a:r>
-              <a:t>•  Column names contain trailing spaces (e.g., "FATIGUE ", "ALLERGY "); trim whitespace to avoid downstream bugs.</a:t>
+              <a:t>•  All symptom and exposure columns are integer-scaled, likely on a uniform rating (e.g., 0-1 or 0-5), simplifying preprocessing.</a:t>
             </a:r>
           </a:p>
           <a:p>
@@ -3408,7 +3410,7 @@
               </a:defRPr>
             </a:pPr>
             <a:r>
-              <a:t>•  All symptom scores are integer-scaled, likely 0-1 or 0-2; verify the coding scheme before model training.</a:t>
+              <a:t>•  Column names contain trailing spaces (e.g., "FATIGUE ", "ALLERGY "); trim whitespace to avoid feature-engineer errors.</a:t>
             </a:r>
           </a:p>
         </p:txBody>
@@ -3499,7 +3501,7 @@
               </a:defRPr>
             </a:pPr>
             <a:r>
-              <a:t>•  Immediate next step: encode categorical gender and target, and standardize feature names for reproducibility.</a:t>
+              <a:t>•  Immediate next step: encode GENDER and LUNG_CANCER (e.g., one-hot or label encoding) and standardize numeric features for model stability.</a:t>
             </a:r>
           </a:p>
           <a:p>
@@ -3514,7 +3516,7 @@
               </a:defRPr>
             </a:pPr>
             <a:r>
-              <a:t>•  Explore age-stratified risk; the two younger outliers may reveal early-onset patterns worth investigating.</a:t>
+              <a:t>•  Evaluate feature importance; symptoms such as YELLOW_FINGERS, WHEEZING, and SHORTNESS OF BREATH are strong clinical indicators for lung cancer risk.</a:t>
             </a:r>
           </a:p>
           <a:p>
@@ -3529,7 +3531,7 @@
               </a:defRPr>
             </a:pPr>
             <a:r>
-              <a:t>•  Leverage the fully observed dataset to prototype rapid lung-cancer risk models (logistic regression, tree-based) for clinical decision support.</a:t>
+              <a:t>•  Consider age binning or transformation to mitigate the impact of the two low-age outliers on model performance.</a:t>
             </a:r>
           </a:p>
           <a:p>
@@ -3544,11 +3546,165 @@
               </a:defRPr>
             </a:pPr>
             <a:r>
-              <a:t>•  Prioritize feature importance analysis to identify high-impact symptoms (e.g., YELLOW_FINGERS, WHEEZING) for targeted screening programs.</a:t>
-            </a:r>
-          </a:p>
-        </p:txBody>
-      </p:sp>
+              <a:t>•  Clean column names and verify consistent scoring scales before deploying any predictive pipeline in a clinical decision-support system.</a:t>
+            </a:r>
+          </a:p>
+        </p:txBody>
+      </p:sp>
+    </p:spTree>
+  </p:cSld>
+  <p:clrMapOvr>
+    <a:masterClrMapping/>
+  </p:clrMapOvr>
+</p:sld>
+</file>
+
+<file path=ppt/slides/slide5.xml><?xml version="1.0" encoding="utf-8"?>
+<p:sld xmlns:a="http://schemas.openxmlformats.org/drawingml/2006/main" xmlns:p="http://schemas.openxmlformats.org/presentationml/2006/main" xmlns:r="http://schemas.openxmlformats.org/officeDocument/2006/relationships">
+  <p:cSld>
+    <p:spTree>
+      <p:nvGrpSpPr>
+        <p:cNvPr id="1" name=""/>
+        <p:cNvGrpSpPr/>
+        <p:nvPr/>
+      </p:nvGrpSpPr>
+      <p:grpSpPr/>
+      <p:sp>
+        <p:nvSpPr>
+          <p:cNvPr id="2" name="TextBox 1"/>
+          <p:cNvSpPr txBox="1"/>
+          <p:nvPr/>
+        </p:nvSpPr>
+        <p:spPr>
+          <a:xfrm>
+            <a:off x="914400" y="548640"/>
+            <a:ext cx="10360152" cy="731520"/>
+          </a:xfrm>
+          <a:prstGeom prst="rect">
+            <a:avLst/>
+          </a:prstGeom>
+          <a:noFill/>
+        </p:spPr>
+        <p:txBody>
+          <a:bodyPr wrap="none">
+            <a:spAutoFit/>
+          </a:bodyPr>
+          <a:lstStyle/>
+          <a:p>
+            <a:pPr>
+              <a:defRPr sz="2600" b="1">
+                <a:solidFill>
+                  <a:srgbClr val="16213E"/>
+                </a:solidFill>
+              </a:defRPr>
+            </a:pPr>
+            <a:r>
+              <a:t>Visual Analysis (Exhibit 1)</a:t>
+            </a:r>
+          </a:p>
+        </p:txBody>
+      </p:sp>
+      <p:pic>
+        <p:nvPicPr>
+          <p:cNvPr id="3" name="Picture 2" descr="AGE_distribution.png"/>
+          <p:cNvPicPr>
+            <a:picLocks noChangeAspect="1"/>
+          </p:cNvPicPr>
+          <p:nvPr/>
+        </p:nvPicPr>
+        <p:blipFill>
+          <a:blip r:embed="rId2"/>
+          <a:stretch>
+            <a:fillRect/>
+          </a:stretch>
+        </p:blipFill>
+        <p:spPr>
+          <a:xfrm>
+            <a:off x="1517904" y="1463040"/>
+            <a:ext cx="9144000" cy="6531429"/>
+          </a:xfrm>
+          <a:prstGeom prst="rect">
+            <a:avLst/>
+          </a:prstGeom>
+        </p:spPr>
+      </p:pic>
+    </p:spTree>
+  </p:cSld>
+  <p:clrMapOvr>
+    <a:masterClrMapping/>
+  </p:clrMapOvr>
+</p:sld>
+</file>
+
+<file path=ppt/slides/slide6.xml><?xml version="1.0" encoding="utf-8"?>
+<p:sld xmlns:a="http://schemas.openxmlformats.org/drawingml/2006/main" xmlns:p="http://schemas.openxmlformats.org/presentationml/2006/main" xmlns:r="http://schemas.openxmlformats.org/officeDocument/2006/relationships">
+  <p:cSld>
+    <p:spTree>
+      <p:nvGrpSpPr>
+        <p:cNvPr id="1" name=""/>
+        <p:cNvGrpSpPr/>
+        <p:nvPr/>
+      </p:nvGrpSpPr>
+      <p:grpSpPr/>
+      <p:sp>
+        <p:nvSpPr>
+          <p:cNvPr id="2" name="TextBox 1"/>
+          <p:cNvSpPr txBox="1"/>
+          <p:nvPr/>
+        </p:nvSpPr>
+        <p:spPr>
+          <a:xfrm>
+            <a:off x="914400" y="548640"/>
+            <a:ext cx="10360152" cy="731520"/>
+          </a:xfrm>
+          <a:prstGeom prst="rect">
+            <a:avLst/>
+          </a:prstGeom>
+          <a:noFill/>
+        </p:spPr>
+        <p:txBody>
+          <a:bodyPr wrap="none">
+            <a:spAutoFit/>
+          </a:bodyPr>
+          <a:lstStyle/>
+          <a:p>
+            <a:pPr>
+              <a:defRPr sz="2600" b="1">
+                <a:solidFill>
+                  <a:srgbClr val="16213E"/>
+                </a:solidFill>
+              </a:defRPr>
+            </a:pPr>
+            <a:r>
+              <a:t>Visual Analysis (Exhibit 2)</a:t>
+            </a:r>
+          </a:p>
+        </p:txBody>
+      </p:sp>
+      <p:pic>
+        <p:nvPicPr>
+          <p:cNvPr id="3" name="Picture 2" descr="SMOKING_by_age.png"/>
+          <p:cNvPicPr>
+            <a:picLocks noChangeAspect="1"/>
+          </p:cNvPicPr>
+          <p:nvPr/>
+        </p:nvPicPr>
+        <p:blipFill>
+          <a:blip r:embed="rId2"/>
+          <a:stretch>
+            <a:fillRect/>
+          </a:stretch>
+        </p:blipFill>
+        <p:spPr>
+          <a:xfrm>
+            <a:off x="1517904" y="1463040"/>
+            <a:ext cx="9144000" cy="6531429"/>
+          </a:xfrm>
+          <a:prstGeom prst="rect">
+            <a:avLst/>
+          </a:prstGeom>
+        </p:spPr>
+      </p:pic>
     </p:spTree>
   </p:cSld>
   <p:clrMapOvr>

</xml_diff>